<commit_message>
sanitize prompts and fix pdf export
</commit_message>
<xml_diff>
--- a/exports/quiz.pptx
+++ b/exports/quiz.pptx
@@ -3105,7 +3105,7 @@
           <a:lstStyle/>
           <a:p>
             <a:r>
-              <a:t>Q1: What is the primary function of a compiler?</a:t>
+              <a:t>Q1: What is the main function of corticopontine fibers?</a:t>
             </a:r>
           </a:p>
         </p:txBody>
@@ -3127,22 +3127,22 @@
           <a:p/>
           <a:p>
             <a:r>
-              <a:t>A. To translate source code into machine code.</a:t>
-            </a:r>
-          </a:p>
-          <a:p>
-            <a:r>
-              <a:t>B. To interpret the source code directly.</a:t>
-            </a:r>
-          </a:p>
-          <a:p>
-            <a:r>
-              <a:t>C. To debug the source code.</a:t>
-            </a:r>
-          </a:p>
-          <a:p>
-            <a:r>
-              <a:t>D. To optimize the source code for performance.</a:t>
+              <a:t>A. To provide input to the motor cranial nerve nuclei.</a:t>
+            </a:r>
+          </a:p>
+          <a:p>
+            <a:r>
+              <a:t>B. To provide input to the corticospinal tract.</a:t>
+            </a:r>
+          </a:p>
+          <a:p>
+            <a:r>
+              <a:t>C. To provide input to the reticular formation.</a:t>
+            </a:r>
+          </a:p>
+          <a:p>
+            <a:r>
+              <a:t>D. To provide input to the pallium.</a:t>
             </a:r>
           </a:p>
         </p:txBody>

</xml_diff>

<commit_message>
changed a function name to avoid ambiguity
</commit_message>
<xml_diff>
--- a/exports/quiz.pptx
+++ b/exports/quiz.pptx
@@ -7,6 +7,8 @@
   <p:sldIdLst>
     <p:sldId id="256" r:id="rId7"/>
     <p:sldId id="257" r:id="rId8"/>
+    <p:sldId id="258" r:id="rId9"/>
+    <p:sldId id="259" r:id="rId10"/>
   </p:sldIdLst>
   <p:sldSz cx="9144000" cy="6858000" type="screen4x3"/>
   <p:notesSz cx="6858000" cy="9144000"/>
@@ -3105,7 +3107,7 @@
           <a:lstStyle/>
           <a:p>
             <a:r>
-              <a:t>Q1: What is the main function of corticopontine fibers?</a:t>
+              <a:t>Q1: Which of the following diseases is associated with cerebellar ataxia and progressive dementia?</a:t>
             </a:r>
           </a:p>
         </p:txBody>
@@ -3127,22 +3129,22 @@
           <a:p/>
           <a:p>
             <a:r>
-              <a:t>A. To provide input to the motor cranial nerve nuclei.</a:t>
-            </a:r>
-          </a:p>
-          <a:p>
-            <a:r>
-              <a:t>B. To provide input to the corticospinal tract.</a:t>
-            </a:r>
-          </a:p>
-          <a:p>
-            <a:r>
-              <a:t>C. To provide input to the reticular formation.</a:t>
-            </a:r>
-          </a:p>
-          <a:p>
-            <a:r>
-              <a:t>D. To provide input to the pallium.</a:t>
+              <a:t>A. Kuru</a:t>
+            </a:r>
+          </a:p>
+          <a:p>
+            <a:r>
+              <a:t>B. Creutzfeldt-Jacob disease</a:t>
+            </a:r>
+          </a:p>
+          <a:p>
+            <a:r>
+              <a:t>C. Scrapie</a:t>
+            </a:r>
+          </a:p>
+          <a:p>
+            <a:r>
+              <a:t>D. Mad cow disease</a:t>
             </a:r>
           </a:p>
         </p:txBody>
@@ -3181,6 +3183,158 @@
           <a:lstStyle/>
           <a:p>
             <a:r>
+              <a:t>Q2: Where is caseous material often located?</a:t>
+            </a:r>
+          </a:p>
+        </p:txBody>
+      </p:sp>
+      <p:sp>
+        <p:nvSpPr>
+          <p:cNvPr id="3" name="Content Placeholder 2"/>
+          <p:cNvSpPr>
+            <a:spLocks noGrp="1"/>
+          </p:cNvSpPr>
+          <p:nvPr>
+            <p:ph idx="1"/>
+          </p:nvPr>
+        </p:nvSpPr>
+        <p:spPr/>
+        <p:txBody>
+          <a:bodyPr/>
+          <a:lstStyle/>
+          <a:p/>
+          <a:p>
+            <a:r>
+              <a:t>A. In the basal cisterns</a:t>
+            </a:r>
+          </a:p>
+          <a:p>
+            <a:r>
+              <a:t>B. In the subarachnoid space</a:t>
+            </a:r>
+          </a:p>
+          <a:p>
+            <a:r>
+              <a:t>C. In the convexity of the brain</a:t>
+            </a:r>
+          </a:p>
+          <a:p>
+            <a:r>
+              <a:t>D. In the ventricles</a:t>
+            </a:r>
+          </a:p>
+        </p:txBody>
+      </p:sp>
+    </p:spTree>
+  </p:cSld>
+  <p:clrMapOvr>
+    <a:masterClrMapping/>
+  </p:clrMapOvr>
+</p:sld>
+</file>
+
+<file path=ppt/slides/slide3.xml><?xml version="1.0" encoding="utf-8"?>
+<p:sld xmlns:a="http://schemas.openxmlformats.org/drawingml/2006/main" xmlns:p="http://schemas.openxmlformats.org/presentationml/2006/main" xmlns:r="http://schemas.openxmlformats.org/officeDocument/2006/relationships">
+  <p:cSld>
+    <p:spTree>
+      <p:nvGrpSpPr>
+        <p:cNvPr id="1" name=""/>
+        <p:cNvGrpSpPr/>
+        <p:nvPr/>
+      </p:nvGrpSpPr>
+      <p:grpSpPr/>
+      <p:sp>
+        <p:nvSpPr>
+          <p:cNvPr id="2" name="Title 1"/>
+          <p:cNvSpPr>
+            <a:spLocks noGrp="1"/>
+          </p:cNvSpPr>
+          <p:nvPr>
+            <p:ph type="title"/>
+          </p:nvPr>
+        </p:nvSpPr>
+        <p:spPr/>
+        <p:txBody>
+          <a:bodyPr/>
+          <a:lstStyle/>
+          <a:p>
+            <a:r>
+              <a:t>Q3: What is the main clinical signs of diseases expressing these manifestations include kuru, documented in new guinea where human brains were eaten while prepar - ing bodies for burial, creutzfeldt – jacob dis - ease, shown to be transmittable, scrapie, a disease found in sheep, and mad cow disease?</a:t>
+            </a:r>
+          </a:p>
+        </p:txBody>
+      </p:sp>
+      <p:sp>
+        <p:nvSpPr>
+          <p:cNvPr id="3" name="Content Placeholder 2"/>
+          <p:cNvSpPr>
+            <a:spLocks noGrp="1"/>
+          </p:cNvSpPr>
+          <p:nvPr>
+            <p:ph idx="1"/>
+          </p:nvPr>
+        </p:nvSpPr>
+        <p:spPr/>
+        <p:txBody>
+          <a:bodyPr/>
+          <a:lstStyle/>
+          <a:p/>
+          <a:p>
+            <a:r>
+              <a:t>A. Cerebellar ataxia and progressive dementia</a:t>
+            </a:r>
+          </a:p>
+          <a:p>
+            <a:r>
+              <a:t>B. Tremor and hypotonia</a:t>
+            </a:r>
+          </a:p>
+          <a:p>
+            <a:r>
+              <a:t>C. Spongiform degeneration of cortical neurons in the cerebellum and cerebrum</a:t>
+            </a:r>
+          </a:p>
+          <a:p>
+            <a:r>
+              <a:t>D. Glial proliferation and cytoplasmic vacuoles</a:t>
+            </a:r>
+          </a:p>
+        </p:txBody>
+      </p:sp>
+    </p:spTree>
+  </p:cSld>
+  <p:clrMapOvr>
+    <a:masterClrMapping/>
+  </p:clrMapOvr>
+</p:sld>
+</file>
+
+<file path=ppt/slides/slide4.xml><?xml version="1.0" encoding="utf-8"?>
+<p:sld xmlns:a="http://schemas.openxmlformats.org/drawingml/2006/main" xmlns:p="http://schemas.openxmlformats.org/presentationml/2006/main" xmlns:r="http://schemas.openxmlformats.org/officeDocument/2006/relationships">
+  <p:cSld>
+    <p:spTree>
+      <p:nvGrpSpPr>
+        <p:cNvPr id="1" name=""/>
+        <p:cNvGrpSpPr/>
+        <p:nvPr/>
+      </p:nvGrpSpPr>
+      <p:grpSpPr/>
+      <p:sp>
+        <p:nvSpPr>
+          <p:cNvPr id="2" name="Title 1"/>
+          <p:cNvSpPr>
+            <a:spLocks noGrp="1"/>
+          </p:cNvSpPr>
+          <p:nvPr>
+            <p:ph type="title"/>
+          </p:nvPr>
+        </p:nvSpPr>
+        <p:spPr/>
+        <p:txBody>
+          <a:bodyPr/>
+          <a:lstStyle/>
+          <a:p>
+            <a:r>
               <a:t>Answer Key</a:t>
             </a:r>
           </a:p>
@@ -3203,7 +3357,17 @@
           <a:p/>
           <a:p>
             <a:r>
-              <a:t>1. A</a:t>
+              <a:t>1. B</a:t>
+            </a:r>
+          </a:p>
+          <a:p>
+            <a:r>
+              <a:t>2. A</a:t>
+            </a:r>
+          </a:p>
+          <a:p>
+            <a:r>
+              <a:t>3. A</a:t>
             </a:r>
           </a:p>
         </p:txBody>

</xml_diff>

<commit_message>
improve export of answers
</commit_message>
<xml_diff>
--- a/exports/quiz.pptx
+++ b/exports/quiz.pptx
@@ -3098,28 +3098,28 @@
             <a:spLocks noGrp="1"/>
           </p:cNvSpPr>
           <p:nvPr>
-            <p:ph type="title"/>
-          </p:nvPr>
-        </p:nvSpPr>
-        <p:spPr/>
-        <p:txBody>
-          <a:bodyPr/>
-          <a:lstStyle/>
-          <a:p>
-            <a:r>
-              <a:t>Q1: Which of the following diseases is associated with cerebellar ataxia and progressive dementia?</a:t>
-            </a:r>
-          </a:p>
-        </p:txBody>
-      </p:sp>
-      <p:sp>
-        <p:nvSpPr>
-          <p:cNvPr id="3" name="Content Placeholder 2"/>
-          <p:cNvSpPr>
-            <a:spLocks noGrp="1"/>
-          </p:cNvSpPr>
-          <p:nvPr>
-            <p:ph idx="1"/>
+            <p:ph type="ctrTitle"/>
+          </p:nvPr>
+        </p:nvSpPr>
+        <p:spPr/>
+        <p:txBody>
+          <a:bodyPr/>
+          <a:lstStyle/>
+          <a:p>
+            <a:r>
+              <a:t>Quiz on neurochemicals</a:t>
+            </a:r>
+          </a:p>
+        </p:txBody>
+      </p:sp>
+      <p:sp>
+        <p:nvSpPr>
+          <p:cNvPr id="3" name="Subtitle 2"/>
+          <p:cNvSpPr>
+            <a:spLocks noGrp="1"/>
+          </p:cNvSpPr>
+          <p:nvPr>
+            <p:ph type="subTitle" idx="1"/>
           </p:nvPr>
         </p:nvSpPr>
         <p:spPr/>
@@ -3127,26 +3127,6 @@
           <a:bodyPr/>
           <a:lstStyle/>
           <a:p/>
-          <a:p>
-            <a:r>
-              <a:t>A. Kuru</a:t>
-            </a:r>
-          </a:p>
-          <a:p>
-            <a:r>
-              <a:t>B. Creutzfeldt-Jacob disease</a:t>
-            </a:r>
-          </a:p>
-          <a:p>
-            <a:r>
-              <a:t>C. Scrapie</a:t>
-            </a:r>
-          </a:p>
-          <a:p>
-            <a:r>
-              <a:t>D. Mad cow disease</a:t>
-            </a:r>
-          </a:p>
         </p:txBody>
       </p:sp>
     </p:spTree>
@@ -3183,7 +3163,7 @@
           <a:lstStyle/>
           <a:p>
             <a:r>
-              <a:t>Q2: Where is caseous material often located?</a:t>
+              <a:t>Q1: According to the provided context, which brain structure is primarily associated with the synthesis of dopamine in the human brain?</a:t>
             </a:r>
           </a:p>
         </p:txBody>
@@ -3205,22 +3185,22 @@
           <a:p/>
           <a:p>
             <a:r>
-              <a:t>A. In the basal cisterns</a:t>
-            </a:r>
-          </a:p>
-          <a:p>
-            <a:r>
-              <a:t>B. In the subarachnoid space</a:t>
-            </a:r>
-          </a:p>
-          <a:p>
-            <a:r>
-              <a:t>C. In the convexity of the brain</a:t>
-            </a:r>
-          </a:p>
-          <a:p>
-            <a:r>
-              <a:t>D. In the ventricles</a:t>
+              <a:t>A. Basal ganglia</a:t>
+            </a:r>
+          </a:p>
+          <a:p>
+            <a:r>
+              <a:t>B. Thalamus</a:t>
+            </a:r>
+          </a:p>
+          <a:p>
+            <a:r>
+              <a:t>C. Cerebellum</a:t>
+            </a:r>
+          </a:p>
+          <a:p>
+            <a:r>
+              <a:t>D. Cerebrum</a:t>
             </a:r>
           </a:p>
         </p:txBody>
@@ -3259,7 +3239,7 @@
           <a:lstStyle/>
           <a:p>
             <a:r>
-              <a:t>Q3: What is the main clinical signs of diseases expressing these manifestations include kuru, documented in new guinea where human brains were eaten while prepar - ing bodies for burial, creutzfeldt – jacob dis - ease, shown to be transmittable, scrapie, a disease found in sheep, and mad cow disease?</a:t>
+              <a:t>Answer Key</a:t>
             </a:r>
           </a:p>
         </p:txBody>
@@ -3281,22 +3261,7 @@
           <a:p/>
           <a:p>
             <a:r>
-              <a:t>A. Cerebellar ataxia and progressive dementia</a:t>
-            </a:r>
-          </a:p>
-          <a:p>
-            <a:r>
-              <a:t>B. Tremor and hypotonia</a:t>
-            </a:r>
-          </a:p>
-          <a:p>
-            <a:r>
-              <a:t>C. Spongiform degeneration of cortical neurons in the cerebellum and cerebrum</a:t>
-            </a:r>
-          </a:p>
-          <a:p>
-            <a:r>
-              <a:t>D. Glial proliferation and cytoplasmic vacuoles</a:t>
+              <a:t>1. A</a:t>
             </a:r>
           </a:p>
         </p:txBody>
@@ -3335,7 +3300,7 @@
           <a:lstStyle/>
           <a:p>
             <a:r>
-              <a:t>Answer Key</a:t>
+              <a:t>Sources</a:t>
             </a:r>
           </a:p>
         </p:txBody>
@@ -3357,17 +3322,7 @@
           <a:p/>
           <a:p>
             <a:r>
-              <a:t>1. B</a:t>
-            </a:r>
-          </a:p>
-          <a:p>
-            <a:r>
-              <a:t>2. A</a:t>
-            </a:r>
-          </a:p>
-          <a:p>
-            <a:r>
-              <a:t>3. A</a:t>
+              <a:t>barr_human_nervous_system.pdf | chunk=doc_dd0c01e1_512_00344 | g=512 | pos=344</a:t>
             </a:r>
           </a:p>
         </p:txBody>

</xml_diff>

<commit_message>
Export PDF and other documents through Chat with Agent
</commit_message>
<xml_diff>
--- a/exports/quiz.pptx
+++ b/exports/quiz.pptx
@@ -3107,7 +3107,7 @@
           <a:lstStyle/>
           <a:p>
             <a:r>
-              <a:t>Quiz on neurochemicals</a:t>
+              <a:t>Quiz on Autonomous Nervous System</a:t>
             </a:r>
           </a:p>
         </p:txBody>
@@ -3163,7 +3163,7 @@
           <a:lstStyle/>
           <a:p>
             <a:r>
-              <a:t>Q1: According to the provided context, which brain structure is primarily associated with the synthesis of dopamine in the human brain?</a:t>
+              <a:t>Q1: What are the two main parts of the autonomic nervous system and their primary functions?</a:t>
             </a:r>
           </a:p>
         </p:txBody>
@@ -3185,22 +3185,22 @@
           <a:p/>
           <a:p>
             <a:r>
-              <a:t>A. Basal ganglia</a:t>
-            </a:r>
-          </a:p>
-          <a:p>
-            <a:r>
-              <a:t>B. Thalamus</a:t>
-            </a:r>
-          </a:p>
-          <a:p>
-            <a:r>
-              <a:t>C. Cerebellum</a:t>
-            </a:r>
-          </a:p>
-          <a:p>
-            <a:r>
-              <a:t>D. Cerebrum</a:t>
+              <a:t>A. Sympathetic part - conserves energy, Parasympathetic part - prepares the body for emergencies</a:t>
+            </a:r>
+          </a:p>
+          <a:p>
+            <a:r>
+              <a:t>B. Sympathetic part - prepares the body for emergencies, Parasympathetic part - conserves and restores energy</a:t>
+            </a:r>
+          </a:p>
+          <a:p>
+            <a:r>
+              <a:t>C. Sympathetic part - controls voluntary muscles, Parasympathetic part - controls involuntary muscles</a:t>
+            </a:r>
+          </a:p>
+          <a:p>
+            <a:r>
+              <a:t>D. Sympathetic part - controls glands, Parasympathetic part - controls smooth muscles</a:t>
             </a:r>
           </a:p>
         </p:txBody>
@@ -3261,7 +3261,7 @@
           <a:p/>
           <a:p>
             <a:r>
-              <a:t>1. A</a:t>
+              <a:t>1. B</a:t>
             </a:r>
           </a:p>
         </p:txBody>
@@ -3322,7 +3322,7 @@
           <a:p/>
           <a:p>
             <a:r>
-              <a:t>barr_human_nervous_system.pdf | chunk=doc_dd0c01e1_512_00344 | g=512 | pos=344</a:t>
+              <a:t>Snell Clinical Neuroanatomy.pdf | chunk=doc_e480feef_128_00032 | g=128 | pos=32</a:t>
             </a:r>
           </a:p>
         </p:txBody>

</xml_diff>

<commit_message>
latest quiz exports from demo
</commit_message>
<xml_diff>
--- a/exports/quiz.pptx
+++ b/exports/quiz.pptx
@@ -11,8 +11,6 @@
     <p:sldId id="259" r:id="rId10"/>
     <p:sldId id="260" r:id="rId11"/>
     <p:sldId id="261" r:id="rId12"/>
-    <p:sldId id="262" r:id="rId13"/>
-    <p:sldId id="263" r:id="rId14"/>
   </p:sldIdLst>
   <p:sldSz cx="9144000" cy="6858000" type="screen4x3"/>
   <p:notesSz cx="6858000" cy="9144000"/>
@@ -3111,7 +3109,7 @@
           <a:lstStyle/>
           <a:p>
             <a:r>
-              <a:t>Quiz on Neurochemicals</a:t>
+              <a:t>Quiz on Parts of the brain</a:t>
             </a:r>
           </a:p>
         </p:txBody>
@@ -3167,7 +3165,7 @@
           <a:lstStyle/>
           <a:p>
             <a:r>
-              <a:t>Q1: In the context of neuroscience research from 1999, which two neurotransmitters are noted for their interaction in the human brain stem and its behavioral implications?</a:t>
+              <a:t>Q1: Which part of the brain is primarily responsible for skilled movement?</a:t>
             </a:r>
           </a:p>
         </p:txBody>
@@ -3189,22 +3187,22 @@
           <a:p/>
           <a:p>
             <a:r>
-              <a:t>A. Dopamine and serotonin</a:t>
-            </a:r>
-          </a:p>
-          <a:p>
-            <a:r>
-              <a:t>B. Corticotropin-releasing hormone and serotonin</a:t>
-            </a:r>
-          </a:p>
-          <a:p>
-            <a:r>
-              <a:t>C. Acetylcholine and dopamine</a:t>
-            </a:r>
-          </a:p>
-          <a:p>
-            <a:r>
-              <a:t>D. GABA and glutamate</a:t>
+              <a:t>A. Cerebellum</a:t>
+            </a:r>
+          </a:p>
+          <a:p>
+            <a:r>
+              <a:t>B. Cortex</a:t>
+            </a:r>
+          </a:p>
+          <a:p>
+            <a:r>
+              <a:t>C. Grey matter</a:t>
+            </a:r>
+          </a:p>
+          <a:p>
+            <a:r>
+              <a:t>D. Brain stem</a:t>
             </a:r>
           </a:p>
         </p:txBody>
@@ -3243,7 +3241,7 @@
           <a:lstStyle/>
           <a:p>
             <a:r>
-              <a:t>Q2: In the context of neuroscience research from 1999, which two neurotransmitters are noted for their interaction in the human brain stem and its behavioral implications?</a:t>
+              <a:t>Q2: What are the two main parts of the cerebrum, and where is the diencephalon located in relation to the third ventricle and cerebral aqueduct?</a:t>
             </a:r>
           </a:p>
         </p:txBody>
@@ -3265,22 +3263,22 @@
           <a:p/>
           <a:p>
             <a:r>
-              <a:t>A. Dopamine and serotonin</a:t>
-            </a:r>
-          </a:p>
-          <a:p>
-            <a:r>
-              <a:t>B. GABA and glutamate</a:t>
-            </a:r>
-          </a:p>
-          <a:p>
-            <a:r>
-              <a:t>C. Corticotropin-releasing hormone and serotonin</a:t>
-            </a:r>
-          </a:p>
-          <a:p>
-            <a:r>
-              <a:t>D. Acetylcholine and norepinephrine</a:t>
+              <a:t>A. The cerebrum is divided into the diencephalon and the telencephalon; the diencephalon is located posterior to the third ventricle and anterior to the cerebral aqueduct.</a:t>
+            </a:r>
+          </a:p>
+          <a:p>
+            <a:r>
+              <a:t>B. The cerebrum is divided into the diencephalon and the telencephalon; the diencephalon is located posterior to the cerebral aqueduct and anterior to the third ventricle.</a:t>
+            </a:r>
+          </a:p>
+          <a:p>
+            <a:r>
+              <a:t>C. The cerebrum is divided into the diencephalon and the telencephalon; the diencephalon is located posterior to the third ventricle and anterior to the cerebral aqueduct.</a:t>
+            </a:r>
+          </a:p>
+          <a:p>
+            <a:r>
+              <a:t>D. The cerebrum is divided into the diencephalon and the telencephalon; the diencephalon is located posterior to the cerebral aqueduct and anterior to the third ventricle.</a:t>
             </a:r>
           </a:p>
         </p:txBody>
@@ -3319,7 +3317,7 @@
           <a:lstStyle/>
           <a:p>
             <a:r>
-              <a:t>Q3: What is the estimated space between adjacent elements in the brain's extracell0ular fluid compartment?</a:t>
+              <a:t>Q3: What are the two main parts of the cerebrum, and where is the diencephalon located in relation to the third ventricle and cerebral aqueduct?</a:t>
             </a:r>
           </a:p>
         </p:txBody>
@@ -3341,22 +3339,22 @@
           <a:p/>
           <a:p>
             <a:r>
-              <a:t>A. 100 a</a:t>
-            </a:r>
-          </a:p>
-          <a:p>
-            <a:r>
-              <a:t>B. 200 a</a:t>
-            </a:r>
-          </a:p>
-          <a:p>
-            <a:r>
-              <a:t>C. 300 a</a:t>
-            </a:r>
-          </a:p>
-          <a:p>
-            <a:r>
-              <a:t>D. 400 a</a:t>
+              <a:t>A. The cerebrum is divided into the diencephalon and the telencephalon; the diencephalon is located posterior to the third ventricle and anterior to the cerebral aqueduct.</a:t>
+            </a:r>
+          </a:p>
+          <a:p>
+            <a:r>
+              <a:t>B. The cerebrum is divided into the diencephalon and the telencephalon; the diencephalon is located posterior to the cerebral aqueduct and anterior to the third ventricle.</a:t>
+            </a:r>
+          </a:p>
+          <a:p>
+            <a:r>
+              <a:t>C. The cerebrum is divided into the diencephalon and the telencephalon; the diencephalon is located posterior to the third ventricle and anterior to the cerebral aqueduct.</a:t>
+            </a:r>
+          </a:p>
+          <a:p>
+            <a:r>
+              <a:t>D. The cerebrum is divided into the diencephalon and the telencephalon; the diencephalon is located posterior to the cerebral aqueduct and anterior to the third ventricle.</a:t>
             </a:r>
           </a:p>
         </p:txBody>
@@ -3395,7 +3393,7 @@
           <a:lstStyle/>
           <a:p>
             <a:r>
-              <a:t>Q4: According to the research by Holt DJ, Graybiel AM, and Saper CB in 1997, what is the neurochemical architecture of the human striatum primarily composed of?</a:t>
+              <a:t>Answer Key</a:t>
             </a:r>
           </a:p>
         </p:txBody>
@@ -3417,22 +3415,17 @@
           <a:p/>
           <a:p>
             <a:r>
-              <a:t>A. Serotonin and GABA</a:t>
-            </a:r>
-          </a:p>
-          <a:p>
-            <a:r>
-              <a:t>B. Dopamine and glutamate</a:t>
-            </a:r>
-          </a:p>
-          <a:p>
-            <a:r>
-              <a:t>C. Dopamine and serotonin</a:t>
-            </a:r>
-          </a:p>
-          <a:p>
-            <a:r>
-              <a:t>D. Glutamate and GABA</a:t>
+              <a:t>1. A</a:t>
+            </a:r>
+          </a:p>
+          <a:p>
+            <a:r>
+              <a:t>2. C</a:t>
+            </a:r>
+          </a:p>
+          <a:p>
+            <a:r>
+              <a:t>3. C</a:t>
             </a:r>
           </a:p>
         </p:txBody>
@@ -3471,7 +3464,7 @@
           <a:lstStyle/>
           <a:p>
             <a:r>
-              <a:t>Q5: Which of the following researchers conducted a study on the ultrastructure of nodes of Ranvier in 1959?</a:t>
+              <a:t>Sources</a:t>
             </a:r>
           </a:p>
         </p:txBody>
@@ -3493,184 +3486,17 @@
           <a:p/>
           <a:p>
             <a:r>
-              <a:t>A. de Robertis, E. and Bennett, H. (1954)</a:t>
-            </a:r>
-          </a:p>
-          <a:p>
-            <a:r>
-              <a:t>B. de Robertis, E. and Norinski, W.W. and Saez, F. (1965)</a:t>
-            </a:r>
-          </a:p>
-          <a:p>
-            <a:r>
-              <a:t>C. Robinson, J.D. (1958)</a:t>
-            </a:r>
-          </a:p>
-          <a:p>
-            <a:r>
-              <a:t>D. Robinson, J.D. (1959)</a:t>
-            </a:r>
-          </a:p>
-        </p:txBody>
-      </p:sp>
-    </p:spTree>
-  </p:cSld>
-  <p:clrMapOvr>
-    <a:masterClrMapping/>
-  </p:clrMapOvr>
-</p:sld>
-</file>
-
-<file path=ppt/slides/slide7.xml><?xml version="1.0" encoding="utf-8"?>
-<p:sld xmlns:a="http://schemas.openxmlformats.org/drawingml/2006/main" xmlns:p="http://schemas.openxmlformats.org/presentationml/2006/main" xmlns:r="http://schemas.openxmlformats.org/officeDocument/2006/relationships">
-  <p:cSld>
-    <p:spTree>
-      <p:nvGrpSpPr>
-        <p:cNvPr id="1" name=""/>
-        <p:cNvGrpSpPr/>
-        <p:nvPr/>
-      </p:nvGrpSpPr>
-      <p:grpSpPr/>
-      <p:sp>
-        <p:nvSpPr>
-          <p:cNvPr id="2" name="Title 1"/>
-          <p:cNvSpPr>
-            <a:spLocks noGrp="1"/>
-          </p:cNvSpPr>
-          <p:nvPr>
-            <p:ph type="title"/>
-          </p:nvPr>
-        </p:nvSpPr>
-        <p:spPr/>
-        <p:txBody>
-          <a:bodyPr/>
-          <a:lstStyle/>
-          <a:p>
-            <a:r>
-              <a:t>Answer Key</a:t>
-            </a:r>
-          </a:p>
-        </p:txBody>
-      </p:sp>
-      <p:sp>
-        <p:nvSpPr>
-          <p:cNvPr id="3" name="Content Placeholder 2"/>
-          <p:cNvSpPr>
-            <a:spLocks noGrp="1"/>
-          </p:cNvSpPr>
-          <p:nvPr>
-            <p:ph idx="1"/>
-          </p:nvPr>
-        </p:nvSpPr>
-        <p:spPr/>
-        <p:txBody>
-          <a:bodyPr/>
-          <a:lstStyle/>
-          <a:p/>
-          <a:p>
-            <a:r>
-              <a:t>1. B</a:t>
-            </a:r>
-          </a:p>
-          <a:p>
-            <a:r>
-              <a:t>2. C</a:t>
-            </a:r>
-          </a:p>
-          <a:p>
-            <a:r>
-              <a:t>3. B</a:t>
-            </a:r>
-          </a:p>
-          <a:p>
-            <a:r>
-              <a:t>4. B</a:t>
-            </a:r>
-          </a:p>
-          <a:p>
-            <a:r>
-              <a:t>5. D</a:t>
-            </a:r>
-          </a:p>
-        </p:txBody>
-      </p:sp>
-    </p:spTree>
-  </p:cSld>
-  <p:clrMapOvr>
-    <a:masterClrMapping/>
-  </p:clrMapOvr>
-</p:sld>
-</file>
-
-<file path=ppt/slides/slide8.xml><?xml version="1.0" encoding="utf-8"?>
-<p:sld xmlns:a="http://schemas.openxmlformats.org/drawingml/2006/main" xmlns:p="http://schemas.openxmlformats.org/presentationml/2006/main" xmlns:r="http://schemas.openxmlformats.org/officeDocument/2006/relationships">
-  <p:cSld>
-    <p:spTree>
-      <p:nvGrpSpPr>
-        <p:cNvPr id="1" name=""/>
-        <p:cNvGrpSpPr/>
-        <p:nvPr/>
-      </p:nvGrpSpPr>
-      <p:grpSpPr/>
-      <p:sp>
-        <p:nvSpPr>
-          <p:cNvPr id="2" name="Title 1"/>
-          <p:cNvSpPr>
-            <a:spLocks noGrp="1"/>
-          </p:cNvSpPr>
-          <p:nvPr>
-            <p:ph type="title"/>
-          </p:nvPr>
-        </p:nvSpPr>
-        <p:spPr/>
-        <p:txBody>
-          <a:bodyPr/>
-          <a:lstStyle/>
-          <a:p>
-            <a:r>
-              <a:t>Sources</a:t>
-            </a:r>
-          </a:p>
-        </p:txBody>
-      </p:sp>
-      <p:sp>
-        <p:nvSpPr>
-          <p:cNvPr id="3" name="Content Placeholder 2"/>
-          <p:cNvSpPr>
-            <a:spLocks noGrp="1"/>
-          </p:cNvSpPr>
-          <p:nvPr>
-            <p:ph idx="1"/>
-          </p:nvPr>
-        </p:nvSpPr>
-        <p:spPr/>
-        <p:txBody>
-          <a:bodyPr/>
-          <a:lstStyle/>
-          <a:p/>
-          <a:p>
-            <a:r>
-              <a:t>the_human_nervous_system_Charles_R_Noback.pdf | chunk=doc_99d01612_128_01673 | g=128 | pos=1673</a:t>
-            </a:r>
-          </a:p>
-          <a:p>
-            <a:r>
-              <a:t>the_human_nervous_system_Charles_R_Noback.pdf | chunk=doc_4c5c950b_128_01673 | g=128 | pos=1673</a:t>
-            </a:r>
-          </a:p>
-          <a:p>
-            <a:r>
-              <a:t>Carpenter Human-Neuroanatomy_text.pdf | chunk=doc_96554193_512_00056 | g=512 | pos=56</a:t>
-            </a:r>
-          </a:p>
-          <a:p>
-            <a:r>
-              <a:t>barr_human_nervous_system.pdf | chunk=doc_dd0c01e1_128_01099 | g=128 | pos=1099</a:t>
-            </a:r>
-          </a:p>
-          <a:p>
-            <a:r>
-              <a:t>Carpenter Human-Neuroanatomy_text.pdf | chunk=doc_96554193_512_01027 | g=512 | pos=1027</a:t>
+              <a:t>Ch3slides.pptx | chunk=doc_0fd5eddc_512_00002 | g=512 | pos=2</a:t>
+            </a:r>
+          </a:p>
+          <a:p>
+            <a:r>
+              <a:t>Snell Clinical Neuroanatomy.pdf | chunk=doc_d35be9e1_128_01298 | g=128 | pos=1298</a:t>
+            </a:r>
+          </a:p>
+          <a:p>
+            <a:r>
+              <a:t>Snell Clinical Neuroanatomy.pdf | chunk=doc_a03e906d_128_01298 | g=128 | pos=1298</a:t>
             </a:r>
           </a:p>
         </p:txBody>

</xml_diff>